<commit_message>
docs: add guest resource links and customer follow-up drafts
</commit_message>
<xml_diff>
--- a/docs/customer/TideGrid-Customer-Validation-Deck.pptx
+++ b/docs/customer/TideGrid-Customer-Validation-Deck.pptx
@@ -2,21 +2,21 @@
 <file path=ppt/presentation.xml><?xml version="1.0" encoding="utf-8"?>
 <p:presentation xmlns:p="http://schemas.openxmlformats.org/presentationml/2006/main">
   <p:sldMasterIdLst>
-    <p:sldMasterId xmlns:r="http://schemas.openxmlformats.org/officeDocument/2006/relationships" id="2147483648" r:id="R839737af05594774"/>
+    <p:sldMasterId xmlns:r="http://schemas.openxmlformats.org/officeDocument/2006/relationships" id="2147483648" r:id="Rdbf754ca87b749c2"/>
   </p:sldMasterIdLst>
   <p:notesMasterIdLst>
-    <p:notesMasterId xmlns:r="http://schemas.openxmlformats.org/officeDocument/2006/relationships" r:id="Ra5b1297b16704b81"/>
+    <p:notesMasterId xmlns:r="http://schemas.openxmlformats.org/officeDocument/2006/relationships" r:id="R4138f217ec61451b"/>
   </p:notesMasterIdLst>
   <p:sldIdLst>
-    <p:sldId xmlns:r="http://schemas.openxmlformats.org/officeDocument/2006/relationships" id="256" r:id="R703bdf72d3634a86"/>
-    <p:sldId xmlns:r="http://schemas.openxmlformats.org/officeDocument/2006/relationships" id="257" r:id="R300c92682cad46ba"/>
-    <p:sldId xmlns:r="http://schemas.openxmlformats.org/officeDocument/2006/relationships" id="258" r:id="R44c925eef12d4e19"/>
-    <p:sldId xmlns:r="http://schemas.openxmlformats.org/officeDocument/2006/relationships" id="259" r:id="R4f811b1de70c4f26"/>
-    <p:sldId xmlns:r="http://schemas.openxmlformats.org/officeDocument/2006/relationships" id="260" r:id="Rb7c52f048b22407e"/>
-    <p:sldId xmlns:r="http://schemas.openxmlformats.org/officeDocument/2006/relationships" id="261" r:id="R1726ee53ea214105"/>
-    <p:sldId xmlns:r="http://schemas.openxmlformats.org/officeDocument/2006/relationships" id="262" r:id="R2125bd38c0ba4f95"/>
-    <p:sldId xmlns:r="http://schemas.openxmlformats.org/officeDocument/2006/relationships" id="263" r:id="Rc514a381b65f40b4"/>
-    <p:sldId xmlns:r="http://schemas.openxmlformats.org/officeDocument/2006/relationships" id="264" r:id="R710ec0d748ee4859"/>
+    <p:sldId xmlns:r="http://schemas.openxmlformats.org/officeDocument/2006/relationships" id="256" r:id="Rb940d82fb0d24a14"/>
+    <p:sldId xmlns:r="http://schemas.openxmlformats.org/officeDocument/2006/relationships" id="257" r:id="R2fe7adf3e15849c7"/>
+    <p:sldId xmlns:r="http://schemas.openxmlformats.org/officeDocument/2006/relationships" id="258" r:id="R83ccb086d2b547cc"/>
+    <p:sldId xmlns:r="http://schemas.openxmlformats.org/officeDocument/2006/relationships" id="259" r:id="R2b4d9abb4ce44526"/>
+    <p:sldId xmlns:r="http://schemas.openxmlformats.org/officeDocument/2006/relationships" id="260" r:id="R9d12c9bdebdc49f8"/>
+    <p:sldId xmlns:r="http://schemas.openxmlformats.org/officeDocument/2006/relationships" id="261" r:id="R40b70a254c294478"/>
+    <p:sldId xmlns:r="http://schemas.openxmlformats.org/officeDocument/2006/relationships" id="262" r:id="R254fd108412945e6"/>
+    <p:sldId xmlns:r="http://schemas.openxmlformats.org/officeDocument/2006/relationships" id="263" r:id="R8edb091269234ff2"/>
+    <p:sldId xmlns:r="http://schemas.openxmlformats.org/officeDocument/2006/relationships" id="264" r:id="Rd717d38ee08848dc"/>
   </p:sldIdLst>
   <p:sldSz cx="12192000" cy="6858000"/>
   <p:notesSz cx="6858000" cy="9144000"/>
@@ -1243,7 +1243,7 @@
   </p:cSld>
   <p:clrMap bg1="lt1" tx1="dk1" bg2="lt2" tx2="dk2" accent1="accent1" accent2="accent2" accent3="accent3" accent4="accent4" accent5="accent5" accent6="accent6" hlink="hlink" folHlink="folHlink"/>
   <p:sldLayoutIdLst>
-    <p:sldLayoutId xmlns:r="http://schemas.openxmlformats.org/officeDocument/2006/relationships" id="2147483649" r:id="R5a9f6056852e4e51"/>
+    <p:sldLayoutId xmlns:r="http://schemas.openxmlformats.org/officeDocument/2006/relationships" id="2147483649" r:id="R467882fd058e4eb7"/>
   </p:sldLayoutIdLst>
   <p:txStyles>
     <p:titleStyle>
@@ -3674,7 +3674,7 @@
                 <a:ea typeface="Arial"/>
                 <a:cs typeface="Arial"/>
               </a:rPr>
-              <a:t>Both would use the same trips, bookings, customer details, and payments. You would not manage two separate systems.</a:t>
+              <a:t>Both would share bookings and payments. You could edit an Important links section in each, such as where to get a fishing license.</a:t>
             </a:r>
           </a:p>
         </p:txBody>
@@ -5386,7 +5386,8 @@
                 <a:ea typeface="Arial"/>
                 <a:cs typeface="Arial"/>
               </a:rPr>
-              <a:t>Sign waivers and read arrival instructions</a:t>
+              <a:t>Sign waivers and read arrival instructions
+Open Important links, such as fishing licenses</a:t>
             </a:r>
           </a:p>
         </p:txBody>

</xml_diff>